<commit_message>
Rehace la captura del perfil y el deck
La del perfil se arma de dos tomas: la pagina no entra en la ventana
y el menu lateral es sticky, asi que la segunda toma lo repetia en la
costura. Se vuelve a pintar esa franja con el color del lienzo.
</commit_message>
<xml_diff>
--- a/EyeLecture-walkthrough-2026-09.pptx
+++ b/EyeLecture-walkthrough-2026-09.pptx
@@ -4191,8 +4191,8 @@
         </p:nvSpPr>
         <p:spPr>
           <a:xfrm>
-            <a:off x="2870198" y="1527048"/>
-            <a:ext cx="6466844" cy="5010912"/>
+            <a:off x="3432053" y="1527048"/>
+            <a:ext cx="5343133" cy="5010912"/>
           </a:xfrm>
           <a:prstGeom prst="roundRect">
             <a:avLst>
@@ -4233,8 +4233,8 @@
         </p:blipFill>
         <p:spPr>
           <a:xfrm>
-            <a:off x="2952494" y="1609344"/>
-            <a:ext cx="6302252" cy="4846320"/>
+            <a:off x="3514349" y="1609344"/>
+            <a:ext cx="5178541" cy="4846320"/>
           </a:xfrm>
           <a:prstGeom prst="rect">
             <a:avLst/>

</xml_diff>

<commit_message>
Captura del dashboard sin "Unaffiliated", y deck
</commit_message>
<xml_diff>
--- a/EyeLecture-walkthrough-2026-09.pptx
+++ b/EyeLecture-walkthrough-2026-09.pptx
@@ -4550,8 +4550,8 @@
         </p:nvSpPr>
         <p:spPr>
           <a:xfrm>
-            <a:off x="739859" y="1527048"/>
-            <a:ext cx="10727522" cy="5010912"/>
+            <a:off x="1412748" y="1527048"/>
+            <a:ext cx="9381744" cy="5010912"/>
           </a:xfrm>
           <a:prstGeom prst="roundRect">
             <a:avLst>
@@ -4592,8 +4592,8 @@
         </p:blipFill>
         <p:spPr>
           <a:xfrm>
-            <a:off x="822155" y="1609344"/>
-            <a:ext cx="10562930" cy="4846320"/>
+            <a:off x="1495044" y="1609344"/>
+            <a:ext cx="9217152" cy="4846320"/>
           </a:xfrm>
           <a:prstGeom prst="rect">
             <a:avLst/>

</xml_diff>